<commit_message>
Resonance deck: raise management fee to 25k/75k/1.25L, cascade all figures
Repriced management fee; recomputed total outflow, monthly & yearly savings,
first-year-net-of-setup, and the slide-12 full-year fee card (4-20L) + admissions-
to-break-even (1-6). Replaced the "keep 3-4 per 1" hook (now false — fee exceeds
monthly saving) with an honest salary-plus-admissions line.

Co-Authored-By: Claude Opus 4.8 <noreply@anthropic.com>
</commit_message>
<xml_diff>
--- a/Admissions-AI-Pitch-Resonance.pptx
+++ b/Admissions-AI-Pitch-Resonance.pptx
@@ -778,7 +778,7 @@
           <a:p>
             <a:r>
               <a:rPr lang="en-US" dirty="0"/>
-              <a:t>The 10x slide. Deliver slowly: "She does not need to be perfect. She needs to save one or two admissions a year that a missed call would have lost. Everything past that is profit — and we have not even counted the salaries yet."</a:t>
+              <a:t>The 10x slide. Deliver slowly: "She does not need to be perfect. She needs to save a few admissions a year that a missed call would have lost. Everything past that is profit — and we have not even counted the salaries yet."</a:t>
             </a:r>
             <a:endParaRPr lang="en-US" dirty="0"/>
           </a:p>
@@ -4768,7 +4768,7 @@
                           <a:ea typeface="Calibri" pitchFamily="34" charset="-122"/>
                           <a:cs typeface="Calibri" pitchFamily="34" charset="-120"/>
                         </a:rPr>
-                        <a:t>₹10,000</a:t>
+                        <a:t>₹25,000</a:t>
                       </a:r>
                       <a:endParaRPr lang="en-US" sz="1250" dirty="0">
                         <a:latin typeface="Calibri" charset="0"/>
@@ -4836,7 +4836,7 @@
                           <a:ea typeface="Calibri" pitchFamily="34" charset="-122"/>
                           <a:cs typeface="Calibri" pitchFamily="34" charset="-120"/>
                         </a:rPr>
-                        <a:t>₹25,000</a:t>
+                        <a:t>₹75,000</a:t>
                       </a:r>
                       <a:endParaRPr lang="en-US" sz="1250" dirty="0">
                         <a:latin typeface="Calibri" charset="0"/>
@@ -4904,7 +4904,7 @@
                           <a:ea typeface="Calibri" pitchFamily="34" charset="-122"/>
                           <a:cs typeface="Calibri" pitchFamily="34" charset="-120"/>
                         </a:rPr>
-                        <a:t>₹50,000</a:t>
+                        <a:t>₹1,25,000</a:t>
                       </a:r>
                       <a:endParaRPr lang="en-US" sz="1250" dirty="0">
                         <a:latin typeface="Calibri" charset="0"/>
@@ -5042,7 +5042,7 @@
                           <a:ea typeface="Calibri" pitchFamily="34" charset="-122"/>
                           <a:cs typeface="Calibri" pitchFamily="34" charset="-120"/>
                         </a:rPr>
-                        <a:t>≈ ₹46,000</a:t>
+                        <a:t>≈ ₹61,000</a:t>
                       </a:r>
                       <a:endParaRPr lang="en-US" sz="1250" dirty="0">
                         <a:latin typeface="Calibri" charset="0"/>
@@ -5110,7 +5110,7 @@
                           <a:ea typeface="Calibri" pitchFamily="34" charset="-122"/>
                           <a:cs typeface="Calibri" pitchFamily="34" charset="-120"/>
                         </a:rPr>
-                        <a:t>≈ ₹1,26,000</a:t>
+                        <a:t>≈ ₹1,76,000</a:t>
                       </a:r>
                       <a:endParaRPr lang="en-US" sz="1250" dirty="0">
                         <a:latin typeface="Calibri" charset="0"/>
@@ -5178,7 +5178,7 @@
                           <a:ea typeface="Calibri" pitchFamily="34" charset="-122"/>
                           <a:cs typeface="Calibri" pitchFamily="34" charset="-120"/>
                         </a:rPr>
-                        <a:t>≈ ₹2,55,000</a:t>
+                        <a:t>≈ ₹3,30,000</a:t>
                       </a:r>
                       <a:endParaRPr lang="en-US" sz="1250" dirty="0">
                         <a:latin typeface="Calibri" charset="0"/>
@@ -5590,7 +5590,7 @@
                           <a:ea typeface="Calibri" pitchFamily="34" charset="-122"/>
                           <a:cs typeface="Calibri" pitchFamily="34" charset="-120"/>
                         </a:rPr>
-                        <a:t>≈ ₹29,000 (39%)</a:t>
+                        <a:t>≈ ₹14,000 (19%)</a:t>
                       </a:r>
                       <a:endParaRPr lang="en-US" sz="1250" dirty="0">
                         <a:latin typeface="Calibri" charset="0"/>
@@ -5658,7 +5658,7 @@
                           <a:ea typeface="Calibri" pitchFamily="34" charset="-122"/>
                           <a:cs typeface="Calibri" pitchFamily="34" charset="-120"/>
                         </a:rPr>
-                        <a:t>≈ ₹99,000 (44%)</a:t>
+                        <a:t>≈ ₹49,000 (22%)</a:t>
                       </a:r>
                       <a:endParaRPr lang="en-US" sz="1250" dirty="0">
                         <a:latin typeface="Calibri" charset="0"/>
@@ -5726,7 +5726,7 @@
                           <a:ea typeface="Calibri" pitchFamily="34" charset="-122"/>
                           <a:cs typeface="Calibri" pitchFamily="34" charset="-120"/>
                         </a:rPr>
-                        <a:t>≈ ₹1,95,000 (43%)</a:t>
+                        <a:t>≈ ₹1,20,000 (27%)</a:t>
                       </a:r>
                       <a:endParaRPr lang="en-US" sz="1250" dirty="0">
                         <a:latin typeface="Calibri" charset="0"/>
@@ -5864,7 +5864,7 @@
                           <a:ea typeface="Calibri" pitchFamily="34" charset="-122"/>
                           <a:cs typeface="Calibri" pitchFamily="34" charset="-120"/>
                         </a:rPr>
-                        <a:t>≈ ₹3,48,000</a:t>
+                        <a:t>≈ ₹1,68,000</a:t>
                       </a:r>
                       <a:endParaRPr lang="en-US" sz="1400" dirty="0">
                         <a:latin typeface="Calibri" charset="0"/>
@@ -5932,7 +5932,7 @@
                           <a:ea typeface="Calibri" pitchFamily="34" charset="-122"/>
                           <a:cs typeface="Calibri" pitchFamily="34" charset="-120"/>
                         </a:rPr>
-                        <a:t>≈ ₹11,88,000</a:t>
+                        <a:t>≈ ₹5,88,000</a:t>
                       </a:r>
                       <a:endParaRPr lang="en-US" sz="1400" dirty="0">
                         <a:latin typeface="Calibri" charset="0"/>
@@ -6000,7 +6000,7 @@
                           <a:ea typeface="Calibri" pitchFamily="34" charset="-122"/>
                           <a:cs typeface="Calibri" pitchFamily="34" charset="-120"/>
                         </a:rPr>
-                        <a:t>≈ ₹23,40,000</a:t>
+                        <a:t>≈ ₹14,40,000</a:t>
                       </a:r>
                       <a:endParaRPr lang="en-US" sz="1400" dirty="0">
                         <a:latin typeface="Calibri" charset="0"/>
@@ -6081,7 +6081,7 @@
               <a:buNone/>
             </a:pPr>
             <a:r>
-              <a:rPr lang="en-US" sz="1450" b="1" i="1" dirty="0">
+              <a:rPr lang="en-US" sz="1400" b="1" i="1" dirty="0">
                 <a:solidFill>
                   <a:srgbClr val="6E1B2A"/>
                 </a:solidFill>
@@ -6089,9 +6089,9 @@
                 <a:ea typeface="Calibri" pitchFamily="34" charset="-122"/>
                 <a:cs typeface="Calibri" pitchFamily="34" charset="-120"/>
               </a:rPr>
-              <a:t>For every ₹1 you pay us, you keep ₹3–4 in savings — and our entire fee is less than the salary of two of the people you no longer need to hire.</a:t>
+              <a:t>You replace a ₹75,000–4,50,000 salary bill and still save ₹1.7–14 lakh a year — before Sneha wins you a single extra admission. Add the ones a missed call would have lost, and it isn’t close.</a:t>
             </a:r>
-            <a:endParaRPr lang="en-US" sz="1450" dirty="0"/>
+            <a:endParaRPr lang="en-US" sz="1400" dirty="0"/>
           </a:p>
         </p:txBody>
       </p:sp>
@@ -6128,7 +6128,7 @@
                 <a:ea typeface="Calibri" pitchFamily="34" charset="-122"/>
                 <a:cs typeface="Calibri" pitchFamily="34" charset="-120"/>
               </a:rPr>
-              <a:t>Vendor accounts in your name, bills visible to you, +GST as applicable. Monthly totals assume modelled call volumes; your real bill follows your real minutes. First-year saving net of one-time setup: ≈ ₹2,48,000 · ₹8,88,000 · ₹18,40,000.</a:t>
+              <a:t>Vendor accounts in your name, bills visible to you, +GST as applicable. Monthly totals assume modelled call volumes; your real bill follows your real minutes. First-year saving net of one-time setup: ≈ ₹68,000 · ₹2,88,000 · ₹9,40,000.</a:t>
             </a:r>
             <a:endParaRPr lang="en-US" sz="1050" dirty="0"/>
           </a:p>
@@ -6487,7 +6487,7 @@
                 <a:ea typeface="Cambria" pitchFamily="34" charset="-122"/>
                 <a:cs typeface="Cambria" pitchFamily="34" charset="-120"/>
               </a:rPr>
-              <a:t>₹2.2–11 lakh</a:t>
+              <a:t>₹4–20 lakh</a:t>
             </a:r>
             <a:endParaRPr lang="en-US" sz="2900" dirty="0"/>
           </a:p>
@@ -6631,7 +6631,7 @@
                 <a:ea typeface="Cambria" pitchFamily="34" charset="-122"/>
                 <a:cs typeface="Cambria" pitchFamily="34" charset="-120"/>
               </a:rPr>
-              <a:t>1–3 admissions</a:t>
+              <a:t>1–6 admissions</a:t>
             </a:r>
             <a:endParaRPr lang="en-US" sz="2900" dirty="0"/>
           </a:p>

</xml_diff>